<commit_message>
I've done some testing.
</commit_message>
<xml_diff>
--- a/NLP Sunum.pptx
+++ b/NLP Sunum.pptx
@@ -1,36 +1,43 @@
 
 <file path=ppt/presentation.xml><?xml version="1.0" encoding="utf-8"?>
-<p:presentation xmlns:a="http://schemas.openxmlformats.org/drawingml/2006/main" xmlns:r="http://schemas.openxmlformats.org/officeDocument/2006/relationships" xmlns:p="http://schemas.openxmlformats.org/presentationml/2006/main" saveSubsetFonts="1" embedTrueTypeFonts="true">
+<p:presentation xmlns:a="http://schemas.openxmlformats.org/drawingml/2006/main" xmlns:r="http://schemas.openxmlformats.org/officeDocument/2006/relationships" xmlns:p="http://schemas.openxmlformats.org/presentationml/2006/main" embedTrueTypeFonts="1" saveSubsetFonts="1">
   <p:sldMasterIdLst>
     <p:sldMasterId id="2147483648" r:id="rId1"/>
   </p:sldMasterIdLst>
   <p:sldIdLst>
-    <p:sldId id="256" r:id="rId6"/>
-    <p:sldId id="257" r:id="rId7"/>
-    <p:sldId id="258" r:id="rId8"/>
-    <p:sldId id="259" r:id="rId9"/>
-    <p:sldId id="260" r:id="rId10"/>
-    <p:sldId id="261" r:id="rId11"/>
-    <p:sldId id="262" r:id="rId12"/>
-    <p:sldId id="263" r:id="rId13"/>
+    <p:sldId id="256" r:id="rId2"/>
+    <p:sldId id="257" r:id="rId3"/>
+    <p:sldId id="258" r:id="rId4"/>
+    <p:sldId id="259" r:id="rId5"/>
+    <p:sldId id="260" r:id="rId6"/>
+    <p:sldId id="261" r:id="rId7"/>
+    <p:sldId id="262" r:id="rId8"/>
+    <p:sldId id="263" r:id="rId9"/>
   </p:sldIdLst>
   <p:sldSz cx="18288000" cy="10287000"/>
   <p:notesSz cx="6858000" cy="9144000"/>
   <p:embeddedFontLst>
     <p:embeddedFont>
-      <p:font typeface="Public Sans Bold" charset="1" panose="00000000000000000000"/>
-      <p:regular r:id="rId14"/>
+      <p:font typeface="Playfair Display" panose="020B0604020202020204" charset="0"/>
+      <p:regular r:id="rId10"/>
     </p:embeddedFont>
     <p:embeddedFont>
-      <p:font typeface="Playfair Display" charset="1" panose="00000500000000000000"/>
-      <p:regular r:id="rId15"/>
+      <p:font typeface="Public Sans" panose="020B0604020202020204" charset="0"/>
+      <p:regular r:id="rId11"/>
     </p:embeddedFont>
     <p:embeddedFont>
-      <p:font typeface="Public Sans" charset="1" panose="00000000000000000000"/>
-      <p:regular r:id="rId16"/>
+      <p:font typeface="Playfair Display Bold" panose="020B0604020202020204" charset="0"/>
+      <p:regular r:id="rId12"/>
     </p:embeddedFont>
     <p:embeddedFont>
-      <p:font typeface="Playfair Display Bold" charset="1" panose="00000800000000000000"/>
+      <p:font typeface="Calibri" panose="020F0502020204030204" pitchFamily="34" charset="0"/>
+      <p:regular r:id="rId13"/>
+      <p:bold r:id="rId14"/>
+      <p:italic r:id="rId15"/>
+      <p:boldItalic r:id="rId16"/>
+    </p:embeddedFont>
+    <p:embeddedFont>
+      <p:font typeface="Public Sans Bold" panose="020B0604020202020204" charset="0"/>
       <p:regular r:id="rId17"/>
     </p:embeddedFont>
   </p:embeddedFontLst>
@@ -129,6 +136,22 @@
       </a:defRPr>
     </a:lvl9pPr>
   </p:defaultTextStyle>
+  <p:extLst>
+    <p:ext uri="{EFAFB233-063F-42B5-8137-9DF3F51BA10A}">
+      <p15:sldGuideLst xmlns:p15="http://schemas.microsoft.com/office/powerpoint/2012/main">
+        <p15:guide id="1" orient="horz" pos="2160">
+          <p15:clr>
+            <a:srgbClr val="A4A3A4"/>
+          </p15:clr>
+        </p15:guide>
+        <p15:guide id="2" pos="2880">
+          <p15:clr>
+            <a:srgbClr val="A4A3A4"/>
+          </p15:clr>
+        </p15:guide>
+      </p15:sldGuideLst>
+    </p:ext>
+  </p:extLst>
 </p:presentation>
 </file>
 
@@ -314,7 +337,7 @@
             <a:fld id="{1D8BD707-D9CF-40AE-B4C6-C98DA3205C09}" type="datetimeFigureOut">
               <a:rPr lang="en-US" smtClean="0"/>
               <a:pPr/>
-              <a:t>8/1/2011</a:t>
+              <a:t>5/11/2026</a:t>
             </a:fld>
             <a:endParaRPr lang="en-US"/>
           </a:p>
@@ -481,7 +504,7 @@
             <a:fld id="{1D8BD707-D9CF-40AE-B4C6-C98DA3205C09}" type="datetimeFigureOut">
               <a:rPr lang="en-US" smtClean="0"/>
               <a:pPr/>
-              <a:t>8/1/2011</a:t>
+              <a:t>5/11/2026</a:t>
             </a:fld>
             <a:endParaRPr lang="en-US"/>
           </a:p>
@@ -658,7 +681,7 @@
             <a:fld id="{1D8BD707-D9CF-40AE-B4C6-C98DA3205C09}" type="datetimeFigureOut">
               <a:rPr lang="en-US" smtClean="0"/>
               <a:pPr/>
-              <a:t>8/1/2011</a:t>
+              <a:t>5/11/2026</a:t>
             </a:fld>
             <a:endParaRPr lang="en-US"/>
           </a:p>
@@ -825,7 +848,7 @@
             <a:fld id="{1D8BD707-D9CF-40AE-B4C6-C98DA3205C09}" type="datetimeFigureOut">
               <a:rPr lang="en-US" smtClean="0"/>
               <a:pPr/>
-              <a:t>8/1/2011</a:t>
+              <a:t>5/11/2026</a:t>
             </a:fld>
             <a:endParaRPr lang="en-US"/>
           </a:p>
@@ -1068,7 +1091,7 @@
             <a:fld id="{1D8BD707-D9CF-40AE-B4C6-C98DA3205C09}" type="datetimeFigureOut">
               <a:rPr lang="en-US" smtClean="0"/>
               <a:pPr/>
-              <a:t>8/1/2011</a:t>
+              <a:t>5/11/2026</a:t>
             </a:fld>
             <a:endParaRPr lang="en-US"/>
           </a:p>
@@ -1353,7 +1376,7 @@
             <a:fld id="{1D8BD707-D9CF-40AE-B4C6-C98DA3205C09}" type="datetimeFigureOut">
               <a:rPr lang="en-US" smtClean="0"/>
               <a:pPr/>
-              <a:t>8/1/2011</a:t>
+              <a:t>5/11/2026</a:t>
             </a:fld>
             <a:endParaRPr lang="en-US"/>
           </a:p>
@@ -1772,7 +1795,7 @@
             <a:fld id="{1D8BD707-D9CF-40AE-B4C6-C98DA3205C09}" type="datetimeFigureOut">
               <a:rPr lang="en-US" smtClean="0"/>
               <a:pPr/>
-              <a:t>8/1/2011</a:t>
+              <a:t>5/11/2026</a:t>
             </a:fld>
             <a:endParaRPr lang="en-US"/>
           </a:p>
@@ -1887,7 +1910,7 @@
             <a:fld id="{1D8BD707-D9CF-40AE-B4C6-C98DA3205C09}" type="datetimeFigureOut">
               <a:rPr lang="en-US" smtClean="0"/>
               <a:pPr/>
-              <a:t>8/1/2011</a:t>
+              <a:t>5/11/2026</a:t>
             </a:fld>
             <a:endParaRPr lang="en-US"/>
           </a:p>
@@ -1979,7 +2002,7 @@
             <a:fld id="{1D8BD707-D9CF-40AE-B4C6-C98DA3205C09}" type="datetimeFigureOut">
               <a:rPr lang="en-US" smtClean="0"/>
               <a:pPr/>
-              <a:t>8/1/2011</a:t>
+              <a:t>5/11/2026</a:t>
             </a:fld>
             <a:endParaRPr lang="en-US"/>
           </a:p>
@@ -2253,7 +2276,7 @@
             <a:fld id="{1D8BD707-D9CF-40AE-B4C6-C98DA3205C09}" type="datetimeFigureOut">
               <a:rPr lang="en-US" smtClean="0"/>
               <a:pPr/>
-              <a:t>8/1/2011</a:t>
+              <a:t>5/11/2026</a:t>
             </a:fld>
             <a:endParaRPr lang="en-US"/>
           </a:p>
@@ -2503,7 +2526,7 @@
             <a:fld id="{1D8BD707-D9CF-40AE-B4C6-C98DA3205C09}" type="datetimeFigureOut">
               <a:rPr lang="en-US" smtClean="0"/>
               <a:pPr/>
-              <a:t>8/1/2011</a:t>
+              <a:t>5/11/2026</a:t>
             </a:fld>
             <a:endParaRPr lang="en-US"/>
           </a:p>
@@ -2713,7 +2736,7 @@
             <a:fld id="{1D8BD707-D9CF-40AE-B4C6-C98DA3205C09}" type="datetimeFigureOut">
               <a:rPr lang="en-US" smtClean="0"/>
               <a:pPr/>
-              <a:t>8/1/2011</a:t>
+              <a:t>5/11/2026</a:t>
             </a:fld>
             <a:endParaRPr lang="en-US"/>
           </a:p>
@@ -3068,13 +3091,14 @@
 </file>
 
 <file path=ppt/slides/slide1.xml><?xml version="1.0" encoding="utf-8"?>
-<p:sld xmlns:p="http://schemas.openxmlformats.org/presentationml/2006/main" xmlns:a="http://schemas.openxmlformats.org/drawingml/2006/main">
+<p:sld xmlns:a="http://schemas.openxmlformats.org/drawingml/2006/main" xmlns:r="http://schemas.openxmlformats.org/officeDocument/2006/relationships" xmlns:p="http://schemas.openxmlformats.org/presentationml/2006/main">
   <p:cSld>
     <p:bg>
       <p:bgPr>
         <a:solidFill>
           <a:srgbClr val="EFEEE7"/>
         </a:solidFill>
+        <a:effectLst/>
       </p:bgPr>
     </p:bg>
     <p:spTree>
@@ -3093,36 +3117,36 @@
       </p:grpSpPr>
       <p:sp>
         <p:nvSpPr>
-          <p:cNvPr name="AutoShape 2" id="2"/>
+          <p:cNvPr id="2" name="AutoShape 2"/>
           <p:cNvSpPr/>
           <p:nvPr/>
         </p:nvSpPr>
         <p:spPr>
-          <a:xfrm flipV="true">
+          <a:xfrm flipV="1">
             <a:off x="1028706" y="4514765"/>
             <a:ext cx="16230594" cy="38509"/>
           </a:xfrm>
           <a:prstGeom prst="line">
             <a:avLst/>
           </a:prstGeom>
-          <a:ln cap="flat" w="9525">
+          <a:ln w="9525" cap="flat">
             <a:solidFill>
               <a:srgbClr val="2B2C30"/>
             </a:solidFill>
             <a:prstDash val="solid"/>
-            <a:headEnd type="none" len="sm" w="sm"/>
-            <a:tailEnd type="none" len="sm" w="sm"/>
+            <a:headEnd type="none" w="sm" len="sm"/>
+            <a:tailEnd type="none" w="sm" len="sm"/>
           </a:ln>
         </p:spPr>
       </p:sp>
       <p:sp>
         <p:nvSpPr>
-          <p:cNvPr name="TextBox 3" id="3"/>
-          <p:cNvSpPr txBox="true"/>
+          <p:cNvPr id="3" name="TextBox 3"/>
+          <p:cNvSpPr txBox="1"/>
           <p:nvPr/>
         </p:nvSpPr>
         <p:spPr>
-          <a:xfrm rot="0">
+          <a:xfrm>
             <a:off x="1006882" y="4728792"/>
             <a:ext cx="16230600" cy="651099"/>
           </a:xfrm>
@@ -3131,7 +3155,7 @@
           </a:prstGeom>
         </p:spPr>
         <p:txBody>
-          <a:bodyPr anchor="t" rtlCol="false" tIns="0" lIns="0" bIns="0" rIns="0">
+          <a:bodyPr lIns="0" tIns="0" rIns="0" bIns="0" rtlCol="0" anchor="t">
             <a:spAutoFit/>
           </a:bodyPr>
           <a:lstStyle/>
@@ -3145,7 +3169,7 @@
               </a:spcBef>
             </a:pPr>
             <a:r>
-              <a:rPr lang="en-US" b="true" sz="3714" spc="843">
+              <a:rPr lang="en-US" sz="3714" b="1" spc="843">
                 <a:solidFill>
                   <a:srgbClr val="2B2C30"/>
                 </a:solidFill>
@@ -3161,12 +3185,12 @@
       </p:sp>
       <p:sp>
         <p:nvSpPr>
-          <p:cNvPr name="TextBox 4" id="4"/>
-          <p:cNvSpPr txBox="true"/>
+          <p:cNvPr id="4" name="TextBox 4"/>
+          <p:cNvSpPr txBox="1"/>
           <p:nvPr/>
         </p:nvSpPr>
         <p:spPr>
-          <a:xfrm rot="0">
+          <a:xfrm>
             <a:off x="850974" y="2332416"/>
             <a:ext cx="16408332" cy="2084083"/>
           </a:xfrm>
@@ -3175,7 +3199,7 @@
           </a:prstGeom>
         </p:spPr>
         <p:txBody>
-          <a:bodyPr anchor="t" rtlCol="false" tIns="0" lIns="0" bIns="0" rIns="0">
+          <a:bodyPr lIns="0" tIns="0" rIns="0" bIns="0" rtlCol="0" anchor="t">
             <a:spAutoFit/>
           </a:bodyPr>
           <a:lstStyle/>
@@ -3202,12 +3226,12 @@
       </p:sp>
       <p:sp>
         <p:nvSpPr>
-          <p:cNvPr name="TextBox 5" id="5"/>
-          <p:cNvSpPr txBox="true"/>
+          <p:cNvPr id="5" name="TextBox 5"/>
+          <p:cNvSpPr txBox="1"/>
           <p:nvPr/>
         </p:nvSpPr>
         <p:spPr>
-          <a:xfrm rot="0">
+          <a:xfrm>
             <a:off x="1016407" y="6726555"/>
             <a:ext cx="3392558" cy="2617470"/>
           </a:xfrm>
@@ -3216,7 +3240,7 @@
           </a:prstGeom>
         </p:spPr>
         <p:txBody>
-          <a:bodyPr anchor="t" rtlCol="false" tIns="0" lIns="0" bIns="0" rIns="0">
+          <a:bodyPr lIns="0" tIns="0" rIns="0" bIns="0" rtlCol="0" anchor="t">
             <a:spAutoFit/>
           </a:bodyPr>
           <a:lstStyle/>
@@ -3321,17 +3345,26 @@
                 <a:spcPts val="3450"/>
               </a:lnSpc>
             </a:pPr>
-          </a:p>
-        </p:txBody>
-      </p:sp>
-      <p:sp>
-        <p:nvSpPr>
-          <p:cNvPr name="TextBox 6" id="6"/>
-          <p:cNvSpPr txBox="true"/>
+            <a:endParaRPr lang="en-US" sz="2300">
+              <a:solidFill>
+                <a:srgbClr val="2B2C30"/>
+              </a:solidFill>
+              <a:latin typeface="Public Sans"/>
+              <a:ea typeface="Public Sans"/>
+              <a:cs typeface="Public Sans"/>
+              <a:sym typeface="Public Sans"/>
+            </a:endParaRPr>
+          </a:p>
+        </p:txBody>
+      </p:sp>
+      <p:sp>
+        <p:nvSpPr>
+          <p:cNvPr id="6" name="TextBox 6"/>
+          <p:cNvSpPr txBox="1"/>
           <p:nvPr/>
         </p:nvSpPr>
         <p:spPr>
-          <a:xfrm rot="0">
+          <a:xfrm>
             <a:off x="4408966" y="6726555"/>
             <a:ext cx="3392558" cy="2179320"/>
           </a:xfrm>
@@ -3340,7 +3373,7 @@
           </a:prstGeom>
         </p:spPr>
         <p:txBody>
-          <a:bodyPr anchor="t" rtlCol="false" tIns="0" lIns="0" bIns="0" rIns="0">
+          <a:bodyPr lIns="0" tIns="0" rIns="0" bIns="0" rtlCol="0" anchor="t">
             <a:spAutoFit/>
           </a:bodyPr>
           <a:lstStyle/>
@@ -3450,13 +3483,14 @@
 </file>
 
 <file path=ppt/slides/slide2.xml><?xml version="1.0" encoding="utf-8"?>
-<p:sld xmlns:p="http://schemas.openxmlformats.org/presentationml/2006/main" xmlns:a="http://schemas.openxmlformats.org/drawingml/2006/main">
+<p:sld xmlns:a="http://schemas.openxmlformats.org/drawingml/2006/main" xmlns:r="http://schemas.openxmlformats.org/officeDocument/2006/relationships" xmlns:p="http://schemas.openxmlformats.org/presentationml/2006/main">
   <p:cSld>
     <p:bg>
       <p:bgPr>
         <a:solidFill>
           <a:srgbClr val="EFEEE7"/>
         </a:solidFill>
+        <a:effectLst/>
       </p:bgPr>
     </p:bg>
     <p:spTree>
@@ -3475,21 +3509,21 @@
       </p:grpSpPr>
       <p:sp>
         <p:nvSpPr>
-          <p:cNvPr name="TextBox 2" id="2"/>
-          <p:cNvSpPr txBox="true"/>
+          <p:cNvPr id="2" name="TextBox 2"/>
+          <p:cNvSpPr txBox="1"/>
           <p:nvPr/>
         </p:nvSpPr>
         <p:spPr>
-          <a:xfrm rot="0">
+          <a:xfrm>
             <a:off x="1028700" y="971550"/>
-            <a:ext cx="14300367" cy="970910"/>
+            <a:ext cx="14300367" cy="1013098"/>
           </a:xfrm>
           <a:prstGeom prst="rect">
             <a:avLst/>
           </a:prstGeom>
         </p:spPr>
         <p:txBody>
-          <a:bodyPr anchor="t" rtlCol="false" tIns="0" lIns="0" bIns="0" rIns="0">
+          <a:bodyPr lIns="0" tIns="0" rIns="0" bIns="0" rtlCol="0" anchor="t">
             <a:spAutoFit/>
           </a:bodyPr>
           <a:lstStyle/>
@@ -3500,7 +3534,7 @@
               </a:lnSpc>
             </a:pPr>
             <a:r>
-              <a:rPr lang="en-US" sz="6050" spc="30">
+              <a:rPr lang="en-US" sz="6050" spc="30" dirty="0">
                 <a:solidFill>
                   <a:srgbClr val="2B2C30"/>
                 </a:solidFill>
@@ -3509,19 +3543,67 @@
                 <a:cs typeface="Playfair Display"/>
                 <a:sym typeface="Playfair Display"/>
               </a:rPr>
-              <a:t>Selected Model: Qwen-2.5-15B Instruct</a:t>
-            </a:r>
-          </a:p>
-        </p:txBody>
-      </p:sp>
-      <p:sp>
-        <p:nvSpPr>
-          <p:cNvPr name="TextBox 3" id="3"/>
-          <p:cNvSpPr txBox="true"/>
+              <a:t>Selected Model: </a:t>
+            </a:r>
+            <a:r>
+              <a:rPr lang="en-US" sz="6050" spc="30" dirty="0" smtClean="0">
+                <a:solidFill>
+                  <a:srgbClr val="2B2C30"/>
+                </a:solidFill>
+                <a:latin typeface="Playfair Display"/>
+                <a:ea typeface="Playfair Display"/>
+                <a:cs typeface="Playfair Display"/>
+                <a:sym typeface="Playfair Display"/>
+              </a:rPr>
+              <a:t>Qwen-2.5-1</a:t>
+            </a:r>
+            <a:r>
+              <a:rPr lang="tr-TR" sz="6050" spc="30" smtClean="0">
+                <a:solidFill>
+                  <a:srgbClr val="2B2C30"/>
+                </a:solidFill>
+                <a:latin typeface="Playfair Display"/>
+                <a:ea typeface="Playfair Display"/>
+                <a:cs typeface="Playfair Display"/>
+                <a:sym typeface="Playfair Display"/>
+              </a:rPr>
+              <a:t>.</a:t>
+            </a:r>
+            <a:r>
+              <a:rPr lang="en-US" sz="6050" spc="30" smtClean="0">
+                <a:solidFill>
+                  <a:srgbClr val="2B2C30"/>
+                </a:solidFill>
+                <a:latin typeface="Playfair Display"/>
+                <a:ea typeface="Playfair Display"/>
+                <a:cs typeface="Playfair Display"/>
+                <a:sym typeface="Playfair Display"/>
+              </a:rPr>
+              <a:t>5B </a:t>
+            </a:r>
+            <a:r>
+              <a:rPr lang="en-US" sz="6050" spc="30">
+                <a:solidFill>
+                  <a:srgbClr val="2B2C30"/>
+                </a:solidFill>
+                <a:latin typeface="Playfair Display"/>
+                <a:ea typeface="Playfair Display"/>
+                <a:cs typeface="Playfair Display"/>
+                <a:sym typeface="Playfair Display"/>
+              </a:rPr>
+              <a:t>Instruct</a:t>
+            </a:r>
+          </a:p>
+        </p:txBody>
+      </p:sp>
+      <p:sp>
+        <p:nvSpPr>
+          <p:cNvPr id="3" name="TextBox 3"/>
+          <p:cNvSpPr txBox="1"/>
           <p:nvPr/>
         </p:nvSpPr>
         <p:spPr>
-          <a:xfrm rot="0">
+          <a:xfrm>
             <a:off x="1028700" y="2401626"/>
             <a:ext cx="15329067" cy="2415540"/>
           </a:xfrm>
@@ -3530,7 +3612,7 @@
           </a:prstGeom>
         </p:spPr>
         <p:txBody>
-          <a:bodyPr anchor="t" rtlCol="false" tIns="0" lIns="0" bIns="0" rIns="0">
+          <a:bodyPr lIns="0" tIns="0" rIns="0" bIns="0" rtlCol="0" anchor="t">
             <a:spAutoFit/>
           </a:bodyPr>
           <a:lstStyle/>
@@ -3553,19 +3635,7 @@
                 <a:cs typeface="Public Sans"/>
                 <a:sym typeface="Public Sans"/>
               </a:rPr>
-              <a:t>As a key member of the Qwen2.5 family, this model stands </a:t>
-            </a:r>
-            <a:r>
-              <a:rPr lang="en-US" sz="2599">
-                <a:solidFill>
-                  <a:srgbClr val="2B2C30"/>
-                </a:solidFill>
-                <a:latin typeface="Public Sans"/>
-                <a:ea typeface="Public Sans"/>
-                <a:cs typeface="Public Sans"/>
-                <a:sym typeface="Public Sans"/>
-              </a:rPr>
-              <a:t>out due to its advanced architecture developed across a wide scale of parameters (0.5B to 72B). We selected this model primarily for its significant improvements in pre-training and post-training stages, which enhance its instruction-following capabilities. Its proven performance in the 1.5B range makes it a robust candidate for efficient fine-tuning and baseline comparison.</a:t>
+              <a:t>As a key member of the Qwen2.5 family, this model stands out due to its advanced architecture developed across a wide scale of parameters (0.5B to 72B). We selected this model primarily for its significant improvements in pre-training and post-training stages, which enhance its instruction-following capabilities. Its proven performance in the 1.5B range makes it a robust candidate for efficient fine-tuning and baseline comparison.</a:t>
             </a:r>
           </a:p>
         </p:txBody>
@@ -3579,13 +3649,14 @@
 </file>
 
 <file path=ppt/slides/slide3.xml><?xml version="1.0" encoding="utf-8"?>
-<p:sld xmlns:p="http://schemas.openxmlformats.org/presentationml/2006/main" xmlns:a="http://schemas.openxmlformats.org/drawingml/2006/main">
+<p:sld xmlns:a="http://schemas.openxmlformats.org/drawingml/2006/main" xmlns:r="http://schemas.openxmlformats.org/officeDocument/2006/relationships" xmlns:p="http://schemas.openxmlformats.org/presentationml/2006/main">
   <p:cSld>
     <p:bg>
       <p:bgPr>
         <a:solidFill>
           <a:srgbClr val="EFEEE7"/>
         </a:solidFill>
+        <a:effectLst/>
       </p:bgPr>
     </p:bg>
     <p:spTree>
@@ -3604,12 +3675,12 @@
       </p:grpSpPr>
       <p:sp>
         <p:nvSpPr>
-          <p:cNvPr name="TextBox 2" id="2"/>
-          <p:cNvSpPr txBox="true"/>
+          <p:cNvPr id="2" name="TextBox 2"/>
+          <p:cNvSpPr txBox="1"/>
           <p:nvPr/>
         </p:nvSpPr>
         <p:spPr>
-          <a:xfrm rot="0">
+          <a:xfrm>
             <a:off x="1028700" y="971550"/>
             <a:ext cx="14300367" cy="970910"/>
           </a:xfrm>
@@ -3618,7 +3689,7 @@
           </a:prstGeom>
         </p:spPr>
         <p:txBody>
-          <a:bodyPr anchor="t" rtlCol="false" tIns="0" lIns="0" bIns="0" rIns="0">
+          <a:bodyPr lIns="0" tIns="0" rIns="0" bIns="0" rtlCol="0" anchor="t">
             <a:spAutoFit/>
           </a:bodyPr>
           <a:lstStyle/>
@@ -3645,12 +3716,12 @@
       </p:sp>
       <p:sp>
         <p:nvSpPr>
-          <p:cNvPr name="TextBox 3" id="3"/>
-          <p:cNvSpPr txBox="true"/>
+          <p:cNvPr id="3" name="TextBox 3"/>
+          <p:cNvSpPr txBox="1"/>
           <p:nvPr/>
         </p:nvSpPr>
         <p:spPr>
-          <a:xfrm rot="0">
+          <a:xfrm>
             <a:off x="1028700" y="2364381"/>
             <a:ext cx="14566667" cy="2415540"/>
           </a:xfrm>
@@ -3659,7 +3730,7 @@
           </a:prstGeom>
         </p:spPr>
         <p:txBody>
-          <a:bodyPr anchor="t" rtlCol="false" tIns="0" lIns="0" bIns="0" rIns="0">
+          <a:bodyPr lIns="0" tIns="0" rIns="0" bIns="0" rtlCol="0" anchor="t">
             <a:spAutoFit/>
           </a:bodyPr>
           <a:lstStyle/>
@@ -3682,19 +3753,7 @@
                 <a:cs typeface="Public Sans"/>
                 <a:sym typeface="Public Sans"/>
               </a:rPr>
-              <a:t>Devel</a:t>
-            </a:r>
-            <a:r>
-              <a:rPr lang="en-US" sz="2599">
-                <a:solidFill>
-                  <a:srgbClr val="2B2C30"/>
-                </a:solidFill>
-                <a:latin typeface="Public Sans"/>
-                <a:ea typeface="Public Sans"/>
-                <a:cs typeface="Public Sans"/>
-                <a:sym typeface="Public Sans"/>
-              </a:rPr>
-              <a:t>oped by Meta, Llama-3.2-1B was chosen for its specialized focus on multilingual support and high efficiency in small-scale models. Being part of a world-class model family, it provides a standardized benchmark for instruction-tuned performance. Including this model allows for a diverse comparative analysis, as it offers a different architectural approach than the Qwen family while maintaining a similar parameter footprint.</a:t>
+              <a:t>Developed by Meta, Llama-3.2-1B was chosen for its specialized focus on multilingual support and high efficiency in small-scale models. Being part of a world-class model family, it provides a standardized benchmark for instruction-tuned performance. Including this model allows for a diverse comparative analysis, as it offers a different architectural approach than the Qwen family while maintaining a similar parameter footprint.</a:t>
             </a:r>
           </a:p>
         </p:txBody>
@@ -3708,13 +3767,14 @@
 </file>
 
 <file path=ppt/slides/slide4.xml><?xml version="1.0" encoding="utf-8"?>
-<p:sld xmlns:p="http://schemas.openxmlformats.org/presentationml/2006/main" xmlns:a="http://schemas.openxmlformats.org/drawingml/2006/main">
+<p:sld xmlns:a="http://schemas.openxmlformats.org/drawingml/2006/main" xmlns:r="http://schemas.openxmlformats.org/officeDocument/2006/relationships" xmlns:p="http://schemas.openxmlformats.org/presentationml/2006/main">
   <p:cSld>
     <p:bg>
       <p:bgPr>
         <a:solidFill>
           <a:srgbClr val="EFEEE7"/>
         </a:solidFill>
+        <a:effectLst/>
       </p:bgPr>
     </p:bg>
     <p:spTree>
@@ -3733,12 +3793,12 @@
       </p:grpSpPr>
       <p:sp>
         <p:nvSpPr>
-          <p:cNvPr name="TextBox 2" id="2"/>
-          <p:cNvSpPr txBox="true"/>
+          <p:cNvPr id="2" name="TextBox 2"/>
+          <p:cNvSpPr txBox="1"/>
           <p:nvPr/>
         </p:nvSpPr>
         <p:spPr>
-          <a:xfrm rot="0">
+          <a:xfrm>
             <a:off x="1006871" y="942975"/>
             <a:ext cx="16230600" cy="651099"/>
           </a:xfrm>
@@ -3747,7 +3807,7 @@
           </a:prstGeom>
         </p:spPr>
         <p:txBody>
-          <a:bodyPr anchor="t" rtlCol="false" tIns="0" lIns="0" bIns="0" rIns="0">
+          <a:bodyPr lIns="0" tIns="0" rIns="0" bIns="0" rtlCol="0" anchor="t">
             <a:spAutoFit/>
           </a:bodyPr>
           <a:lstStyle/>
@@ -3761,7 +3821,7 @@
               </a:spcBef>
             </a:pPr>
             <a:r>
-              <a:rPr lang="en-US" b="true" sz="3714" spc="843">
+              <a:rPr lang="en-US" sz="3714" b="1" spc="843">
                 <a:solidFill>
                   <a:srgbClr val="2B2C30"/>
                 </a:solidFill>
@@ -3777,36 +3837,36 @@
       </p:sp>
       <p:sp>
         <p:nvSpPr>
-          <p:cNvPr name="AutoShape 3" id="3"/>
+          <p:cNvPr id="3" name="AutoShape 3"/>
           <p:cNvSpPr/>
           <p:nvPr/>
         </p:nvSpPr>
         <p:spPr>
-          <a:xfrm flipV="true">
+          <a:xfrm flipV="1">
             <a:off x="1028695" y="1760761"/>
             <a:ext cx="16230594" cy="38509"/>
           </a:xfrm>
           <a:prstGeom prst="line">
             <a:avLst/>
           </a:prstGeom>
-          <a:ln cap="flat" w="9525">
+          <a:ln w="9525" cap="flat">
             <a:solidFill>
               <a:srgbClr val="2B2C30"/>
             </a:solidFill>
             <a:prstDash val="solid"/>
-            <a:headEnd type="none" len="sm" w="sm"/>
-            <a:tailEnd type="none" len="sm" w="sm"/>
+            <a:headEnd type="none" w="sm" len="sm"/>
+            <a:tailEnd type="none" w="sm" len="sm"/>
           </a:ln>
         </p:spPr>
       </p:sp>
       <p:sp>
         <p:nvSpPr>
-          <p:cNvPr name="TextBox 4" id="4"/>
-          <p:cNvSpPr txBox="true"/>
+          <p:cNvPr id="4" name="TextBox 4"/>
+          <p:cNvSpPr txBox="1"/>
           <p:nvPr/>
         </p:nvSpPr>
         <p:spPr>
-          <a:xfrm rot="0">
+          <a:xfrm>
             <a:off x="771525" y="2808736"/>
             <a:ext cx="16744950" cy="2901315"/>
           </a:xfrm>
@@ -3815,12 +3875,12 @@
           </a:prstGeom>
         </p:spPr>
         <p:txBody>
-          <a:bodyPr anchor="t" rtlCol="false" tIns="0" lIns="0" bIns="0" rIns="0">
+          <a:bodyPr lIns="0" tIns="0" rIns="0" bIns="0" rtlCol="0" anchor="t">
             <a:spAutoFit/>
           </a:bodyPr>
           <a:lstStyle/>
           <a:p>
-            <a:pPr algn="l" marL="0" indent="0" lvl="0">
+            <a:pPr marL="0" lvl="0" indent="0" algn="l">
               <a:lnSpc>
                 <a:spcPts val="3899"/>
               </a:lnSpc>
@@ -3829,7 +3889,7 @@
               </a:spcBef>
             </a:pPr>
             <a:r>
-              <a:rPr lang="en-US" sz="2599" strike="noStrike" u="none">
+              <a:rPr lang="en-US" sz="2599" u="none" strike="noStrike">
                 <a:solidFill>
                   <a:srgbClr val="2B2C30"/>
                 </a:solidFill>
@@ -3845,12 +3905,12 @@
       </p:sp>
       <p:sp>
         <p:nvSpPr>
-          <p:cNvPr name="TextBox 5" id="5"/>
-          <p:cNvSpPr txBox="true"/>
+          <p:cNvPr id="5" name="TextBox 5"/>
+          <p:cNvSpPr txBox="1"/>
           <p:nvPr/>
         </p:nvSpPr>
         <p:spPr>
-          <a:xfrm rot="0">
+          <a:xfrm>
             <a:off x="1028700" y="7100683"/>
             <a:ext cx="16744950" cy="527685"/>
           </a:xfrm>
@@ -3859,12 +3919,12 @@
           </a:prstGeom>
         </p:spPr>
         <p:txBody>
-          <a:bodyPr anchor="t" rtlCol="false" tIns="0" lIns="0" bIns="0" rIns="0">
+          <a:bodyPr lIns="0" tIns="0" rIns="0" bIns="0" rtlCol="0" anchor="t">
             <a:spAutoFit/>
           </a:bodyPr>
           <a:lstStyle/>
           <a:p>
-            <a:pPr algn="ctr" marL="0" indent="0" lvl="0">
+            <a:pPr marL="0" lvl="0" indent="0" algn="ctr">
               <a:lnSpc>
                 <a:spcPts val="4349"/>
               </a:lnSpc>
@@ -3873,7 +3933,7 @@
               </a:spcBef>
             </a:pPr>
             <a:r>
-              <a:rPr lang="en-US" b="true" sz="2899">
+              <a:rPr lang="en-US" sz="2899" b="1">
                 <a:solidFill>
                   <a:srgbClr val="2B2C30"/>
                 </a:solidFill>
@@ -3896,13 +3956,14 @@
 </file>
 
 <file path=ppt/slides/slide5.xml><?xml version="1.0" encoding="utf-8"?>
-<p:sld xmlns:p="http://schemas.openxmlformats.org/presentationml/2006/main" xmlns:a="http://schemas.openxmlformats.org/drawingml/2006/main">
+<p:sld xmlns:a="http://schemas.openxmlformats.org/drawingml/2006/main" xmlns:r="http://schemas.openxmlformats.org/officeDocument/2006/relationships" xmlns:p="http://schemas.openxmlformats.org/presentationml/2006/main">
   <p:cSld>
     <p:bg>
       <p:bgPr>
         <a:solidFill>
           <a:srgbClr val="EFEEE7"/>
         </a:solidFill>
+        <a:effectLst/>
       </p:bgPr>
     </p:bg>
     <p:spTree>
@@ -3921,12 +3982,12 @@
       </p:grpSpPr>
       <p:sp>
         <p:nvSpPr>
-          <p:cNvPr name="TextBox 2" id="2"/>
-          <p:cNvSpPr txBox="true"/>
+          <p:cNvPr id="2" name="TextBox 2"/>
+          <p:cNvSpPr txBox="1"/>
           <p:nvPr/>
         </p:nvSpPr>
         <p:spPr>
-          <a:xfrm rot="0">
+          <a:xfrm>
             <a:off x="696317" y="2789905"/>
             <a:ext cx="16851708" cy="3302514"/>
           </a:xfrm>
@@ -3935,7 +3996,7 @@
           </a:prstGeom>
         </p:spPr>
         <p:txBody>
-          <a:bodyPr anchor="t" rtlCol="false" tIns="0" lIns="0" bIns="0" rIns="0">
+          <a:bodyPr lIns="0" tIns="0" rIns="0" bIns="0" rtlCol="0" anchor="t">
             <a:spAutoFit/>
           </a:bodyPr>
           <a:lstStyle/>
@@ -4000,12 +4061,12 @@
       </p:sp>
       <p:sp>
         <p:nvSpPr>
-          <p:cNvPr name="TextBox 3" id="3"/>
-          <p:cNvSpPr txBox="true"/>
+          <p:cNvPr id="3" name="TextBox 3"/>
+          <p:cNvSpPr txBox="1"/>
           <p:nvPr/>
         </p:nvSpPr>
         <p:spPr>
-          <a:xfrm rot="0">
+          <a:xfrm>
             <a:off x="1006871" y="942975"/>
             <a:ext cx="16230600" cy="651099"/>
           </a:xfrm>
@@ -4014,7 +4075,7 @@
           </a:prstGeom>
         </p:spPr>
         <p:txBody>
-          <a:bodyPr anchor="t" rtlCol="false" tIns="0" lIns="0" bIns="0" rIns="0">
+          <a:bodyPr lIns="0" tIns="0" rIns="0" bIns="0" rtlCol="0" anchor="t">
             <a:spAutoFit/>
           </a:bodyPr>
           <a:lstStyle/>
@@ -4028,7 +4089,7 @@
               </a:spcBef>
             </a:pPr>
             <a:r>
-              <a:rPr lang="en-US" b="true" sz="3714" spc="843">
+              <a:rPr lang="en-US" sz="3714" b="1" spc="843">
                 <a:solidFill>
                   <a:srgbClr val="2B2C30"/>
                 </a:solidFill>
@@ -4044,25 +4105,25 @@
       </p:sp>
       <p:sp>
         <p:nvSpPr>
-          <p:cNvPr name="AutoShape 4" id="4"/>
+          <p:cNvPr id="4" name="AutoShape 4"/>
           <p:cNvSpPr/>
           <p:nvPr/>
         </p:nvSpPr>
         <p:spPr>
-          <a:xfrm flipV="true">
+          <a:xfrm flipV="1">
             <a:off x="1028695" y="1760761"/>
             <a:ext cx="16230594" cy="38509"/>
           </a:xfrm>
           <a:prstGeom prst="line">
             <a:avLst/>
           </a:prstGeom>
-          <a:ln cap="flat" w="9525">
+          <a:ln w="9525" cap="flat">
             <a:solidFill>
               <a:srgbClr val="2B2C30"/>
             </a:solidFill>
             <a:prstDash val="solid"/>
-            <a:headEnd type="none" len="sm" w="sm"/>
-            <a:tailEnd type="none" len="sm" w="sm"/>
+            <a:headEnd type="none" w="sm" len="sm"/>
+            <a:tailEnd type="none" w="sm" len="sm"/>
           </a:ln>
         </p:spPr>
       </p:sp>
@@ -4075,13 +4136,14 @@
 </file>
 
 <file path=ppt/slides/slide6.xml><?xml version="1.0" encoding="utf-8"?>
-<p:sld xmlns:p="http://schemas.openxmlformats.org/presentationml/2006/main" xmlns:a="http://schemas.openxmlformats.org/drawingml/2006/main" xmlns:r="http://schemas.openxmlformats.org/officeDocument/2006/relationships">
+<p:sld xmlns:a="http://schemas.openxmlformats.org/drawingml/2006/main" xmlns:r="http://schemas.openxmlformats.org/officeDocument/2006/relationships" xmlns:p="http://schemas.openxmlformats.org/presentationml/2006/main">
   <p:cSld>
     <p:bg>
       <p:bgPr>
         <a:solidFill>
           <a:srgbClr val="EFEEE7"/>
         </a:solidFill>
+        <a:effectLst/>
       </p:bgPr>
     </p:bg>
     <p:spTree>
@@ -4100,36 +4162,36 @@
       </p:grpSpPr>
       <p:sp>
         <p:nvSpPr>
-          <p:cNvPr name="AutoShape 2" id="2"/>
+          <p:cNvPr id="2" name="AutoShape 2"/>
           <p:cNvSpPr/>
           <p:nvPr/>
         </p:nvSpPr>
         <p:spPr>
-          <a:xfrm flipV="true">
+          <a:xfrm flipV="1">
             <a:off x="1028695" y="1760761"/>
             <a:ext cx="16230594" cy="38509"/>
           </a:xfrm>
           <a:prstGeom prst="line">
             <a:avLst/>
           </a:prstGeom>
-          <a:ln cap="flat" w="9525">
+          <a:ln w="9525" cap="flat">
             <a:solidFill>
               <a:srgbClr val="2B2C30"/>
             </a:solidFill>
             <a:prstDash val="solid"/>
-            <a:headEnd type="none" len="sm" w="sm"/>
-            <a:tailEnd type="none" len="sm" w="sm"/>
+            <a:headEnd type="none" w="sm" len="sm"/>
+            <a:tailEnd type="none" w="sm" len="sm"/>
           </a:ln>
         </p:spPr>
       </p:sp>
       <p:sp>
         <p:nvSpPr>
-          <p:cNvPr name="Freeform 3" id="3"/>
+          <p:cNvPr id="3" name="Freeform 3"/>
           <p:cNvSpPr/>
           <p:nvPr/>
         </p:nvSpPr>
         <p:spPr>
-          <a:xfrm flipH="false" flipV="false" rot="0">
+          <a:xfrm>
             <a:off x="1654091" y="2371472"/>
             <a:ext cx="14598528" cy="2299268"/>
           </a:xfrm>
@@ -4138,9 +4200,9 @@
             <a:gdLst/>
             <a:ahLst/>
             <a:cxnLst/>
-            <a:rect r="r" b="b" t="t" l="l"/>
+            <a:rect l="l" t="t" r="r" b="b"/>
             <a:pathLst>
-              <a:path h="2299268" w="14598528">
+              <a:path w="14598528" h="2299268">
                 <a:moveTo>
                   <a:pt x="0" y="0"/>
                 </a:moveTo>
@@ -4163,19 +4225,19 @@
           <a:blipFill>
             <a:blip r:embed="rId2"/>
             <a:stretch>
-              <a:fillRect l="0" t="0" r="0" b="0"/>
+              <a:fillRect/>
             </a:stretch>
           </a:blipFill>
         </p:spPr>
       </p:sp>
       <p:sp>
         <p:nvSpPr>
-          <p:cNvPr name="Freeform 4" id="4"/>
+          <p:cNvPr id="4" name="Freeform 4"/>
           <p:cNvSpPr/>
           <p:nvPr/>
         </p:nvSpPr>
         <p:spPr>
-          <a:xfrm flipH="false" flipV="false" rot="0">
+          <a:xfrm>
             <a:off x="1654091" y="5451791"/>
             <a:ext cx="14598528" cy="1973614"/>
           </a:xfrm>
@@ -4184,9 +4246,9 @@
             <a:gdLst/>
             <a:ahLst/>
             <a:cxnLst/>
-            <a:rect r="r" b="b" t="t" l="l"/>
+            <a:rect l="l" t="t" r="r" b="b"/>
             <a:pathLst>
-              <a:path h="1973614" w="14598528">
+              <a:path w="14598528" h="1973614">
                 <a:moveTo>
                   <a:pt x="0" y="0"/>
                 </a:moveTo>
@@ -4209,19 +4271,19 @@
           <a:blipFill>
             <a:blip r:embed="rId3"/>
             <a:stretch>
-              <a:fillRect l="-2103" t="-12730" r="-2103" b="0"/>
+              <a:fillRect l="-2103" t="-12730" r="-2103"/>
             </a:stretch>
           </a:blipFill>
         </p:spPr>
       </p:sp>
       <p:sp>
         <p:nvSpPr>
-          <p:cNvPr name="TextBox 5" id="5"/>
-          <p:cNvSpPr txBox="true"/>
+          <p:cNvPr id="5" name="TextBox 5"/>
+          <p:cNvSpPr txBox="1"/>
           <p:nvPr/>
         </p:nvSpPr>
         <p:spPr>
-          <a:xfrm rot="0">
+          <a:xfrm>
             <a:off x="1006871" y="942975"/>
             <a:ext cx="16230600" cy="651099"/>
           </a:xfrm>
@@ -4230,7 +4292,7 @@
           </a:prstGeom>
         </p:spPr>
         <p:txBody>
-          <a:bodyPr anchor="t" rtlCol="false" tIns="0" lIns="0" bIns="0" rIns="0">
+          <a:bodyPr lIns="0" tIns="0" rIns="0" bIns="0" rtlCol="0" anchor="t">
             <a:spAutoFit/>
           </a:bodyPr>
           <a:lstStyle/>
@@ -4244,7 +4306,7 @@
               </a:spcBef>
             </a:pPr>
             <a:r>
-              <a:rPr lang="en-US" b="true" sz="3714" spc="843">
+              <a:rPr lang="en-US" sz="3714" b="1" spc="843">
                 <a:solidFill>
                   <a:srgbClr val="2B2C30"/>
                 </a:solidFill>
@@ -4267,13 +4329,14 @@
 </file>
 
 <file path=ppt/slides/slide7.xml><?xml version="1.0" encoding="utf-8"?>
-<p:sld xmlns:p="http://schemas.openxmlformats.org/presentationml/2006/main" xmlns:a="http://schemas.openxmlformats.org/drawingml/2006/main">
+<p:sld xmlns:a="http://schemas.openxmlformats.org/drawingml/2006/main" xmlns:r="http://schemas.openxmlformats.org/officeDocument/2006/relationships" xmlns:p="http://schemas.openxmlformats.org/presentationml/2006/main">
   <p:cSld>
     <p:bg>
       <p:bgPr>
         <a:solidFill>
           <a:srgbClr val="EFEEE7"/>
         </a:solidFill>
+        <a:effectLst/>
       </p:bgPr>
     </p:bg>
     <p:spTree>
@@ -4292,12 +4355,12 @@
       </p:grpSpPr>
       <p:sp>
         <p:nvSpPr>
-          <p:cNvPr name="TextBox 2" id="2"/>
-          <p:cNvSpPr txBox="true"/>
+          <p:cNvPr id="2" name="TextBox 2"/>
+          <p:cNvSpPr txBox="1"/>
           <p:nvPr/>
         </p:nvSpPr>
         <p:spPr>
-          <a:xfrm rot="0">
+          <a:xfrm>
             <a:off x="1028700" y="971550"/>
             <a:ext cx="14300367" cy="970910"/>
           </a:xfrm>
@@ -4306,7 +4369,7 @@
           </a:prstGeom>
         </p:spPr>
         <p:txBody>
-          <a:bodyPr anchor="t" rtlCol="false" tIns="0" lIns="0" bIns="0" rIns="0">
+          <a:bodyPr lIns="0" tIns="0" rIns="0" bIns="0" rtlCol="0" anchor="t">
             <a:spAutoFit/>
           </a:bodyPr>
           <a:lstStyle/>
@@ -4333,12 +4396,12 @@
       </p:sp>
       <p:sp>
         <p:nvSpPr>
-          <p:cNvPr name="TextBox 3" id="3"/>
-          <p:cNvSpPr txBox="true"/>
+          <p:cNvPr id="3" name="TextBox 3"/>
+          <p:cNvSpPr txBox="1"/>
           <p:nvPr/>
         </p:nvSpPr>
         <p:spPr>
-          <a:xfrm rot="0">
+          <a:xfrm>
             <a:off x="299418" y="2780093"/>
             <a:ext cx="17667778" cy="4316032"/>
           </a:xfrm>
@@ -4347,12 +4410,12 @@
           </a:prstGeom>
         </p:spPr>
         <p:txBody>
-          <a:bodyPr anchor="t" rtlCol="false" tIns="0" lIns="0" bIns="0" rIns="0">
+          <a:bodyPr lIns="0" tIns="0" rIns="0" bIns="0" rtlCol="0" anchor="t">
             <a:spAutoFit/>
           </a:bodyPr>
           <a:lstStyle/>
           <a:p>
-            <a:pPr algn="l" marL="0" indent="0" lvl="0">
+            <a:pPr marL="0" lvl="0" indent="0" algn="l">
               <a:lnSpc>
                 <a:spcPts val="3776"/>
               </a:lnSpc>
@@ -4361,7 +4424,7 @@
               </a:spcBef>
             </a:pPr>
             <a:r>
-              <a:rPr lang="en-US" sz="2904" spc="14" strike="noStrike" u="none">
+              <a:rPr lang="en-US" sz="2904" u="none" strike="noStrike" spc="14">
                 <a:solidFill>
                   <a:srgbClr val="2B2C30"/>
                 </a:solidFill>
@@ -4374,7 +4437,7 @@
             </a:r>
           </a:p>
           <a:p>
-            <a:pPr algn="l" marL="0" indent="0" lvl="0">
+            <a:pPr marL="0" lvl="0" indent="0" algn="l">
               <a:lnSpc>
                 <a:spcPts val="3776"/>
               </a:lnSpc>
@@ -4382,9 +4445,18 @@
                 <a:spcPct val="0"/>
               </a:spcBef>
             </a:pPr>
-          </a:p>
-          <a:p>
-            <a:pPr algn="l" marL="0" indent="0" lvl="0">
+            <a:endParaRPr lang="en-US" sz="2904" u="none" strike="noStrike" spc="14">
+              <a:solidFill>
+                <a:srgbClr val="2B2C30"/>
+              </a:solidFill>
+              <a:latin typeface="Playfair Display"/>
+              <a:ea typeface="Playfair Display"/>
+              <a:cs typeface="Playfair Display"/>
+              <a:sym typeface="Playfair Display"/>
+            </a:endParaRPr>
+          </a:p>
+          <a:p>
+            <a:pPr marL="0" lvl="0" indent="0" algn="l">
               <a:lnSpc>
                 <a:spcPts val="4166"/>
               </a:lnSpc>
@@ -4393,7 +4465,7 @@
               </a:spcBef>
             </a:pPr>
             <a:r>
-              <a:rPr lang="en-US" sz="3204" spc="16" strike="noStrike" u="none">
+              <a:rPr lang="en-US" sz="3204" u="none" strike="noStrike" spc="16">
                 <a:solidFill>
                   <a:srgbClr val="2B2C30"/>
                 </a:solidFill>
@@ -4405,7 +4477,7 @@
               <a:t> </a:t>
             </a:r>
             <a:r>
-              <a:rPr lang="en-US" b="true" sz="3204" spc="16" strike="noStrike" u="none">
+              <a:rPr lang="en-US" sz="3204" b="1" u="none" strike="noStrike" spc="16">
                 <a:solidFill>
                   <a:srgbClr val="2B2C30"/>
                 </a:solidFill>
@@ -4418,7 +4490,7 @@
             </a:r>
           </a:p>
           <a:p>
-            <a:pPr algn="l" marL="0" indent="0" lvl="0">
+            <a:pPr marL="0" lvl="0" indent="0" algn="l">
               <a:lnSpc>
                 <a:spcPts val="3776"/>
               </a:lnSpc>
@@ -4426,9 +4498,18 @@
                 <a:spcPct val="0"/>
               </a:spcBef>
             </a:pPr>
-          </a:p>
-          <a:p>
-            <a:pPr algn="l" marL="0" indent="0" lvl="0">
+            <a:endParaRPr lang="en-US" sz="3204" b="1" u="none" strike="noStrike" spc="16">
+              <a:solidFill>
+                <a:srgbClr val="2B2C30"/>
+              </a:solidFill>
+              <a:latin typeface="Playfair Display Bold"/>
+              <a:ea typeface="Playfair Display Bold"/>
+              <a:cs typeface="Playfair Display Bold"/>
+              <a:sym typeface="Playfair Display Bold"/>
+            </a:endParaRPr>
+          </a:p>
+          <a:p>
+            <a:pPr marL="0" lvl="0" indent="0" algn="l">
               <a:lnSpc>
                 <a:spcPts val="3776"/>
               </a:lnSpc>
@@ -4436,9 +4517,18 @@
                 <a:spcPct val="0"/>
               </a:spcBef>
             </a:pPr>
-          </a:p>
-          <a:p>
-            <a:pPr algn="l" marL="0" indent="0" lvl="0">
+            <a:endParaRPr lang="en-US" sz="3204" b="1" u="none" strike="noStrike" spc="16">
+              <a:solidFill>
+                <a:srgbClr val="2B2C30"/>
+              </a:solidFill>
+              <a:latin typeface="Playfair Display Bold"/>
+              <a:ea typeface="Playfair Display Bold"/>
+              <a:cs typeface="Playfair Display Bold"/>
+              <a:sym typeface="Playfair Display Bold"/>
+            </a:endParaRPr>
+          </a:p>
+          <a:p>
+            <a:pPr marL="0" lvl="0" indent="0" algn="l">
               <a:lnSpc>
                 <a:spcPts val="3776"/>
               </a:lnSpc>
@@ -4447,7 +4537,7 @@
               </a:spcBef>
             </a:pPr>
             <a:r>
-              <a:rPr lang="en-US" sz="2904" spc="14" strike="noStrike" u="none">
+              <a:rPr lang="en-US" sz="2904" u="none" strike="noStrike" spc="14">
                 <a:solidFill>
                   <a:srgbClr val="2B2C30"/>
                 </a:solidFill>
@@ -4460,7 +4550,7 @@
             </a:r>
           </a:p>
           <a:p>
-            <a:pPr algn="l" marL="0" indent="0" lvl="0">
+            <a:pPr marL="0" lvl="0" indent="0" algn="l">
               <a:lnSpc>
                 <a:spcPts val="3776"/>
               </a:lnSpc>
@@ -4469,7 +4559,7 @@
               </a:spcBef>
             </a:pPr>
             <a:r>
-              <a:rPr lang="en-US" sz="2904" spc="14" strike="noStrike" u="none">
+              <a:rPr lang="en-US" sz="2904" u="none" strike="noStrike" spc="14">
                 <a:solidFill>
                   <a:srgbClr val="2B2C30"/>
                 </a:solidFill>
@@ -4492,13 +4582,14 @@
 </file>
 
 <file path=ppt/slides/slide8.xml><?xml version="1.0" encoding="utf-8"?>
-<p:sld xmlns:p="http://schemas.openxmlformats.org/presentationml/2006/main" xmlns:a="http://schemas.openxmlformats.org/drawingml/2006/main">
+<p:sld xmlns:a="http://schemas.openxmlformats.org/drawingml/2006/main" xmlns:r="http://schemas.openxmlformats.org/officeDocument/2006/relationships" xmlns:p="http://schemas.openxmlformats.org/presentationml/2006/main">
   <p:cSld>
     <p:bg>
       <p:bgPr>
         <a:solidFill>
           <a:srgbClr val="EFEEE7"/>
         </a:solidFill>
+        <a:effectLst/>
       </p:bgPr>
     </p:bg>
     <p:spTree>
@@ -4517,36 +4608,36 @@
       </p:grpSpPr>
       <p:sp>
         <p:nvSpPr>
-          <p:cNvPr name="AutoShape 2" id="2"/>
+          <p:cNvPr id="2" name="AutoShape 2"/>
           <p:cNvSpPr/>
           <p:nvPr/>
         </p:nvSpPr>
         <p:spPr>
-          <a:xfrm flipV="true">
+          <a:xfrm flipV="1">
             <a:off x="1028695" y="1760761"/>
             <a:ext cx="16230594" cy="38509"/>
           </a:xfrm>
           <a:prstGeom prst="line">
             <a:avLst/>
           </a:prstGeom>
-          <a:ln cap="flat" w="9525">
+          <a:ln w="9525" cap="flat">
             <a:solidFill>
               <a:srgbClr val="2B2C30"/>
             </a:solidFill>
             <a:prstDash val="solid"/>
-            <a:headEnd type="none" len="sm" w="sm"/>
-            <a:tailEnd type="none" len="sm" w="sm"/>
+            <a:headEnd type="none" w="sm" len="sm"/>
+            <a:tailEnd type="none" w="sm" len="sm"/>
           </a:ln>
         </p:spPr>
       </p:sp>
       <p:sp>
         <p:nvSpPr>
-          <p:cNvPr name="TextBox 3" id="3"/>
-          <p:cNvSpPr txBox="true"/>
+          <p:cNvPr id="3" name="TextBox 3"/>
+          <p:cNvSpPr txBox="1"/>
           <p:nvPr/>
         </p:nvSpPr>
         <p:spPr>
-          <a:xfrm rot="0">
+          <a:xfrm>
             <a:off x="1006871" y="942975"/>
             <a:ext cx="16230600" cy="651099"/>
           </a:xfrm>
@@ -4555,7 +4646,7 @@
           </a:prstGeom>
         </p:spPr>
         <p:txBody>
-          <a:bodyPr anchor="t" rtlCol="false" tIns="0" lIns="0" bIns="0" rIns="0">
+          <a:bodyPr lIns="0" tIns="0" rIns="0" bIns="0" rtlCol="0" anchor="t">
             <a:spAutoFit/>
           </a:bodyPr>
           <a:lstStyle/>
@@ -4569,7 +4660,7 @@
               </a:spcBef>
             </a:pPr>
             <a:r>
-              <a:rPr lang="en-US" b="true" sz="3714" spc="843">
+              <a:rPr lang="en-US" sz="3714" b="1" spc="843">
                 <a:solidFill>
                   <a:srgbClr val="2B2C30"/>
                 </a:solidFill>
@@ -4585,12 +4676,12 @@
       </p:sp>
       <p:sp>
         <p:nvSpPr>
-          <p:cNvPr name="TextBox 4" id="4"/>
-          <p:cNvSpPr txBox="true"/>
+          <p:cNvPr id="4" name="TextBox 4"/>
+          <p:cNvSpPr txBox="1"/>
           <p:nvPr/>
         </p:nvSpPr>
         <p:spPr>
-          <a:xfrm rot="0">
+          <a:xfrm>
             <a:off x="1028700" y="2180536"/>
             <a:ext cx="11471184" cy="4385310"/>
           </a:xfrm>
@@ -4599,19 +4690,19 @@
           </a:prstGeom>
         </p:spPr>
         <p:txBody>
-          <a:bodyPr anchor="t" rtlCol="false" tIns="0" lIns="0" bIns="0" rIns="0">
+          <a:bodyPr lIns="0" tIns="0" rIns="0" bIns="0" rtlCol="0" anchor="t">
             <a:spAutoFit/>
           </a:bodyPr>
           <a:lstStyle/>
           <a:p>
-            <a:pPr algn="l" marL="604519" indent="-302260" lvl="1">
+            <a:pPr marL="604519" lvl="1" indent="-302260" algn="l">
               <a:lnSpc>
                 <a:spcPts val="5879"/>
               </a:lnSpc>
-              <a:buAutoNum type="arabicPeriod" startAt="1"/>
+              <a:buAutoNum type="arabicPeriod"/>
             </a:pPr>
             <a:r>
-              <a:rPr lang="en-US" b="true" sz="2799">
+              <a:rPr lang="en-US" sz="2799" b="1">
                 <a:solidFill>
                   <a:srgbClr val="2B2C30"/>
                 </a:solidFill>
@@ -4624,14 +4715,14 @@
             </a:r>
           </a:p>
           <a:p>
-            <a:pPr algn="l" marL="604519" indent="-302260" lvl="1">
+            <a:pPr marL="604519" lvl="1" indent="-302260" algn="l">
               <a:lnSpc>
                 <a:spcPts val="5879"/>
               </a:lnSpc>
-              <a:buAutoNum type="arabicPeriod" startAt="1"/>
+              <a:buAutoNum type="arabicPeriod"/>
             </a:pPr>
             <a:r>
-              <a:rPr lang="en-US" b="true" sz="2799">
+              <a:rPr lang="en-US" sz="2799" b="1">
                 <a:solidFill>
                   <a:srgbClr val="2B2C30"/>
                 </a:solidFill>
@@ -4644,14 +4735,14 @@
             </a:r>
           </a:p>
           <a:p>
-            <a:pPr algn="l" marL="604519" indent="-302260" lvl="1">
+            <a:pPr marL="604519" lvl="1" indent="-302260" algn="l">
               <a:lnSpc>
                 <a:spcPts val="5879"/>
               </a:lnSpc>
-              <a:buAutoNum type="arabicPeriod" startAt="1"/>
+              <a:buAutoNum type="arabicPeriod"/>
             </a:pPr>
             <a:r>
-              <a:rPr lang="en-US" b="true" sz="2799">
+              <a:rPr lang="en-US" sz="2799" b="1">
                 <a:solidFill>
                   <a:srgbClr val="2B2C30"/>
                 </a:solidFill>
@@ -4664,14 +4755,14 @@
             </a:r>
           </a:p>
           <a:p>
-            <a:pPr algn="l" marL="604519" indent="-302260" lvl="1">
+            <a:pPr marL="604519" lvl="1" indent="-302260" algn="l">
               <a:lnSpc>
                 <a:spcPts val="5879"/>
               </a:lnSpc>
-              <a:buAutoNum type="arabicPeriod" startAt="1"/>
+              <a:buAutoNum type="arabicPeriod"/>
             </a:pPr>
             <a:r>
-              <a:rPr lang="en-US" b="true" sz="2799">
+              <a:rPr lang="en-US" sz="2799" b="1">
                 <a:solidFill>
                   <a:srgbClr val="2B2C30"/>
                 </a:solidFill>
@@ -4684,14 +4775,14 @@
             </a:r>
           </a:p>
           <a:p>
-            <a:pPr algn="l" marL="604519" indent="-302260" lvl="1">
+            <a:pPr marL="604519" lvl="1" indent="-302260" algn="l">
               <a:lnSpc>
                 <a:spcPts val="5879"/>
               </a:lnSpc>
-              <a:buAutoNum type="arabicPeriod" startAt="1"/>
+              <a:buAutoNum type="arabicPeriod"/>
             </a:pPr>
             <a:r>
-              <a:rPr lang="en-US" b="true" sz="2799">
+              <a:rPr lang="en-US" sz="2799" b="1">
                 <a:solidFill>
                   <a:srgbClr val="2B2C30"/>
                 </a:solidFill>
@@ -4704,14 +4795,14 @@
             </a:r>
           </a:p>
           <a:p>
-            <a:pPr algn="l" marL="604519" indent="-302260" lvl="1">
+            <a:pPr marL="604519" lvl="1" indent="-302260" algn="l">
               <a:lnSpc>
                 <a:spcPts val="5879"/>
               </a:lnSpc>
-              <a:buAutoNum type="arabicPeriod" startAt="1"/>
+              <a:buAutoNum type="arabicPeriod"/>
             </a:pPr>
             <a:r>
-              <a:rPr lang="en-US" b="true" sz="2799">
+              <a:rPr lang="en-US" sz="2799" b="1">
                 <a:solidFill>
                   <a:srgbClr val="2B2C30"/>
                 </a:solidFill>

</xml_diff>